<commit_message>
docs: bring the documents up to date with signed requests
- Architecture review: N5 (replay of client API requests) closed by ADR-036; 36 ADRs.
- Design: the API contract mentions signed requests; the client console holds credentials in memory only;
  signing secrets and the nonce table in the data section.
- Disaster recovery and production checklist: which encryption keys a database backup depends on, including
  the credentials key that now also protects signing secrets.
- Product deck: a Signed requests card on the security slide; the Postman collection now has 51 requests
  (also in both READMEs).

Co-Authored-By: Claude Opus 5.5 <noreply@anthropic.com>
</commit_message>
<xml_diff>
--- a/docs/presentation/notification-service.pptx
+++ b/docs/presentation/notification-service.pptx
@@ -121,7 +121,7 @@
   <p:extLst>
     <p:ext uri="{521415D9-36F7-43E2-AB2F-B90AF26B5E84}">
       <p14:sectionLst xmlns:p14="http://schemas.microsoft.com/office/powerpoint/2010/main">
-        <p14:section name="Introduction" id="{687d0658-90de-cdb9-6c53-fa0b19021f92}">
+        <p14:section name="Introduction" id="{75da64b3-2a7b-bca1-32d9-39447cf61503}">
           <p14:sldIdLst>
             <p14:sldId id="256"/>
             <p14:sldId id="257"/>
@@ -129,7 +129,7 @@
             <p14:sldId id="259"/>
           </p14:sldIdLst>
         </p14:section>
-        <p14:section name="The product" id="{859e99dd-eb9d-8048-62da-44d24ffedd91}">
+        <p14:section name="The product" id="{65d4ec35-a6ac-27e9-05c7-9037d0f96956}">
           <p14:sldIdLst>
             <p14:sldId id="260"/>
             <p14:sldId id="261"/>
@@ -137,21 +137,21 @@
             <p14:sldId id="263"/>
           </p14:sldIdLst>
         </p14:section>
-        <p14:section name="Business and trust" id="{04d94b93-6a5e-1440-1429-ffa206650ecd}">
+        <p14:section name="Business and trust" id="{f85f70ff-2289-0e60-7f5f-3f2875f59621}">
           <p14:sldIdLst>
             <p14:sldId id="264"/>
             <p14:sldId id="265"/>
             <p14:sldId id="266"/>
           </p14:sldIdLst>
         </p14:section>
-        <p14:section name="Operations and developers" id="{0f20c4c2-93ab-9653-82e9-d493e33b14b3}">
+        <p14:section name="Operations and developers" id="{4dc17aab-d85f-d010-264f-00b5f0d0d157}">
           <p14:sldIdLst>
             <p14:sldId id="267"/>
             <p14:sldId id="268"/>
             <p14:sldId id="269"/>
           </p14:sldIdLst>
         </p14:section>
-        <p14:section name="Closing" id="{b2ffe03f-6b21-b6e1-3d2d-f3a9a0a3469a}">
+        <p14:section name="Closing" id="{931ae2b0-928e-868b-d354-149bd8c9ab1c}">
           <p14:sldIdLst>
             <p14:sldId id="270"/>
           </p14:sldIdLst>
@@ -736,7 +736,7 @@
           <a:p>
             <a:r>
               <a:rPr lang="en-US" dirty="0"/>
-              <a:t>Security is on by default. Administrators must change the initial password and enable two-factor authentication, roles limit who can change what, container images are signed with software bills of materials, provider URLs are checked to prevent server-side request forgery, services refuse to start with development secrets, and every pull request is scanned.</a:t>
+              <a:t>Security is on by default. Administrators must change the initial password and enable two-factor authentication, roles limit who can change what, and tenants can sign their API calls so that a captured or altered request is refused. Provider URLs are checked to prevent server-side request forgery, services refuse to start with development secrets, and container images are signed with software bills of materials while every pull request is scanned.</a:t>
             </a:r>
             <a:endParaRPr lang="en-US" dirty="0"/>
           </a:p>
@@ -3854,7 +3854,7 @@
       </p:sp>
       <p:sp>
         <p:nvSpPr>
-          <p:cNvPr id="11" name="Signed images circle"/>
+          <p:cNvPr id="11" name="Signed requests circle"/>
           <p:cNvSpPr/>
           <p:nvPr/>
         </p:nvSpPr>
@@ -3879,7 +3879,7 @@
       </p:sp>
       <p:pic>
         <p:nvPicPr>
-          <p:cNvPr id="12" name="Signed images icon" descr="Signed images">    </p:cNvPr>
+          <p:cNvPr id="12" name="Signed requests icon" descr="Signed requests">    </p:cNvPr>
           <p:cNvPicPr>
             <a:picLocks noChangeAspect="1"/>
           </p:cNvPicPr>
@@ -3931,7 +3931,7 @@
                   <a:schemeClr val="tx1"/>
                 </a:solidFill>
               </a:rPr>
-              <a:t>Signed images</a:t>
+              <a:t>Signed requests</a:t>
             </a:r>
             <a:endParaRPr lang="en-US" sz="1600" dirty="0"/>
           </a:p>
@@ -3967,7 +3967,7 @@
                   <a:srgbClr val="3D4466"/>
                 </a:solidFill>
               </a:rPr>
-              <a:t>Cosign signatures and SBOMs</a:t>
+              <a:t>Replayed or altered API calls refused</a:t>
             </a:r>
             <a:endParaRPr lang="en-US" sz="1300" dirty="0"/>
           </a:p>
@@ -4217,7 +4217,7 @@
       </p:sp>
       <p:sp>
         <p:nvSpPr>
-          <p:cNvPr id="23" name="Scanned continuously circle"/>
+          <p:cNvPr id="23" name="Trusted supply chain circle"/>
           <p:cNvSpPr/>
           <p:nvPr/>
         </p:nvSpPr>
@@ -4242,7 +4242,7 @@
       </p:sp>
       <p:pic>
         <p:nvPicPr>
-          <p:cNvPr id="24" name="Scanned continuously icon" descr="Scanned continuously">    </p:cNvPr>
+          <p:cNvPr id="24" name="Trusted supply chain icon" descr="Trusted supply chain">    </p:cNvPr>
           <p:cNvPicPr>
             <a:picLocks noChangeAspect="1"/>
           </p:cNvPicPr>
@@ -4294,7 +4294,7 @@
                   <a:schemeClr val="tx1"/>
                 </a:solidFill>
               </a:rPr>
-              <a:t>Scanned continuously</a:t>
+              <a:t>Trusted supply chain</a:t>
             </a:r>
             <a:endParaRPr lang="en-US" sz="1600" dirty="0"/>
           </a:p>
@@ -4330,7 +4330,7 @@
                   <a:srgbClr val="3D4466"/>
                 </a:solidFill>
               </a:rPr>
-              <a:t>CodeQL, dependency and secret scans</a:t>
+              <a:t>Signed images, SBOMs, CodeQL scans</a:t>
             </a:r>
             <a:endParaRPr lang="en-US" sz="1300" dirty="0"/>
           </a:p>
@@ -5787,7 +5787,7 @@
                   <a:srgbClr val="3D4466"/>
                 </a:solidFill>
               </a:rPr>
-              <a:t>50 tested requests across the whole API</a:t>
+              <a:t>51 tested requests across the whole API</a:t>
             </a:r>
             <a:endParaRPr lang="en-US" sz="1300" dirty="0"/>
           </a:p>

</xml_diff>